<commit_message>
COP17: deck de 17 laminas, agrega la lamina de patentes
Nueva lamina antepenultima (11 - Y LAS PATENTES): el barrido de las 99
endemicas de territorio indigena contra la clase PAT del European
Nucleotide Archive. De las 99, 39 son comprobables y ninguna aparece en
una patente; 60 no tienen una sola secuencia, asi que su cero no es
interpretable. De los 70.526.111 registros de patente del ENA, ninguno
declara pais de origen, de ningun pais.

Arregla ademas un defecto del motor de laminas tipo matriz que venia en
el deck publicado: el filete separador de filas tachaba el texto del
monto. Ahora el monto se ancla al pie de la fila y el alto de fila se
reparte el espacio disponible.

Co-Authored-By: Claude Opus 5 (1M context) <noreply@anthropic.com>
</commit_message>
<xml_diff>
--- a/Metodo_MACI_FIIB_ONIC.pptx
+++ b/Metodo_MACI_FIIB_ONIC.pptx
@@ -21,6 +21,7 @@
     <p:sldId id="269" r:id="rId21"/>
     <p:sldId id="270" r:id="rId22"/>
     <p:sldId id="271" r:id="rId23"/>
+    <p:sldId id="272" r:id="rId24"/>
   </p:sldIdLst>
   <p:sldSz cx="12192119" cy="6858000" type="screen4x3"/>
   <p:notesSz cx="6858000" cy="9144000"/>
@@ -944,7 +945,7 @@
           <a:p>
             <a:r>
               <a:rPr sz="1300"/>
-              <a:t>What do we do with this? We did not have to invent the link: each thing we measured justifies, on its own, one of the four lines the organization has been proposing. The name that gets lost calls for an own inventory with a stable identifier. The origin that is not declared calls for labelling that travels with the data. The absence of alerts calls for community monitoring. And the fifty-seven unregistered call for an own genetic bank. And monitoring is not a nice principle. It is the evidence. The turmeric, neem and bean patents were revoked on documented prior art, not on failure to disclose origin. A people that records systematically is manufacturing the one argument that has actually won.</a:t>
+              <a:t>And patents. We were told for months this channel could not be opened. It can, and not through the patent offices: the sequence database itself publishes the sequences disclosed inside patents, with their number. Seventy million of them — more than the ordinary ones. We ran our ninety-nine species against it. Thirty-nine have public sequences, so their zero means something: none of them appears in a patent. Sixty have no sequence at all, so for those we cannot know, and we say so. The result is zero. And the honest headline is not that they patented our plants — it is that nobody has touched them. Put the scale beside it: our most sequenced species has one hundred and thirty-seven sequences; the cultivated potato has four hundred eighteen thousand and three thousand nine hundred patents. We are not saying it was taken from us. We are saying the system is built so that nobody can tell.]</a:t>
             </a:r>
           </a:p>
         </p:txBody>
@@ -970,6 +971,77 @@
 </file>
 
 <file path=ppt/notesSlides/notesSlide16.xml><?xml version="1.0" encoding="utf-8"?>
+<p:notes xmlns:a="http://schemas.openxmlformats.org/drawingml/2006/main" xmlns:p="http://schemas.openxmlformats.org/presentationml/2006/main" xmlns:r="http://schemas.openxmlformats.org/officeDocument/2006/relationships">
+  <p:cSld>
+    <p:spTree>
+      <p:nvGrpSpPr>
+        <p:cNvPr id="1" name=""/>
+        <p:cNvGrpSpPr/>
+        <p:nvPr/>
+      </p:nvGrpSpPr>
+      <p:grpSpPr>
+        <a:xfrm>
+          <a:off x="0" y="0"/>
+          <a:ext cx="0" cy="0"/>
+          <a:chOff x="0" y="0"/>
+          <a:chExt cx="0" cy="0"/>
+        </a:xfrm>
+      </p:grpSpPr>
+      <p:sp>
+        <p:nvSpPr>
+          <p:cNvPr id="2" name="Slide Image Placeholder 1"/>
+          <p:cNvSpPr>
+            <a:spLocks noGrp="1"/>
+          </p:cNvSpPr>
+          <p:nvPr>
+            <p:ph type="sldImg" idx="2"/>
+          </p:nvPr>
+        </p:nvSpPr>
+        <p:spPr/>
+      </p:sp>
+      <p:sp>
+        <p:nvSpPr>
+          <p:cNvPr id="3" name="Notes Placeholder 2"/>
+          <p:cNvSpPr>
+            <a:spLocks noGrp="1"/>
+          </p:cNvSpPr>
+          <p:nvPr>
+            <p:ph type="body" idx="3" sz="quarter"/>
+          </p:nvPr>
+        </p:nvSpPr>
+        <p:spPr/>
+        <p:txBody>
+          <a:bodyPr/>
+          <a:lstStyle/>
+          <a:p>
+            <a:r>
+              <a:rPr sz="1300"/>
+              <a:t>What do we do with this? We did not have to invent the link: each thing we measured justifies, on its own, one of the four lines the organization has been proposing. The name that gets lost calls for an own inventory with a stable identifier. The origin that is not declared calls for labelling that travels with the data. The absence of alerts calls for community monitoring. And the fifty-seven unregistered call for an own genetic bank. And monitoring is not a nice principle. It is the evidence. The turmeric, neem and bean patents were revoked on documented prior art, not on failure to disclose origin. A people that records systematically is manufacturing the one argument that has actually won.</a:t>
+            </a:r>
+          </a:p>
+        </p:txBody>
+      </p:sp>
+      <p:sp>
+        <p:nvSpPr>
+          <p:cNvPr id="4" name="Slide Number Placeholder 3"/>
+          <p:cNvSpPr>
+            <a:spLocks noGrp="1"/>
+          </p:cNvSpPr>
+          <p:nvPr>
+            <p:ph type="sldNum" idx="5" sz="quarter"/>
+          </p:nvPr>
+        </p:nvSpPr>
+        <p:spPr/>
+      </p:sp>
+    </p:spTree>
+  </p:cSld>
+  <p:clrMapOvr>
+    <a:masterClrMapping/>
+  </p:clrMapOvr>
+</p:notes>
+</file>
+
+<file path=ppt/notesSlides/notesSlide17.xml><?xml version="1.0" encoding="utf-8"?>
 <p:notes xmlns:a="http://schemas.openxmlformats.org/drawingml/2006/main" xmlns:p="http://schemas.openxmlformats.org/presentationml/2006/main" xmlns:r="http://schemas.openxmlformats.org/officeDocument/2006/relationships">
   <p:cSld>
     <p:spTree>
@@ -7925,7 +7997,7 @@
                 </a:solidFill>
                 <a:latin typeface="Arial"/>
               </a:rPr>
-              <a:t>11 · QUÉ HACEMOS CON ESTO</a:t>
+              <a:t>11 · Y LAS PATENTES</a:t>
             </a:r>
           </a:p>
         </p:txBody>
@@ -8056,7 +8128,7 @@
                 </a:solidFill>
                 <a:latin typeface="Georgia"/>
               </a:rPr>
-              <a:t>Cada ceguera tiene su respuesta.</a:t>
+              <a:t>Buscamos patentes. No hay ninguna.</a:t>
             </a:r>
           </a:p>
         </p:txBody>
@@ -8095,7 +8167,7 @@
                 </a:solidFill>
                 <a:latin typeface="Arial"/>
               </a:rPr>
-              <a:t>No hubo que inventar el vínculo: cada cosa que medimos justifica, por sí sola, una de las cuatro líneas que la ONIC viene proponiendo.</a:t>
+              <a:t>No hacen falta las oficinas de patentes: la propia base de secuencias publica las que se divulgaron dentro de una patente, con su número.</a:t>
             </a:r>
           </a:p>
         </p:txBody>
@@ -8130,7 +8202,7 @@
                 </a:solidFill>
                 <a:latin typeface="Arial"/>
               </a:rPr>
-              <a:t>LO MEDIDO</a:t>
+              <a:t>DE LAS 99</a:t>
             </a:r>
           </a:p>
         </p:txBody>
@@ -8165,7 +8237,7 @@
                 </a:solidFill>
                 <a:latin typeface="Arial"/>
               </a:rPr>
-              <a:t>POR QUÉ FALLA</a:t>
+              <a:t>QUÉ SE PUDO MEDIR</a:t>
             </a:r>
           </a:p>
         </p:txBody>
@@ -8200,7 +8272,7 @@
                 </a:solidFill>
                 <a:latin typeface="Arial"/>
               </a:rPr>
-              <a:t>LA RESPUESTA</a:t>
+              <a:t>QUÉ DICE</a:t>
             </a:r>
           </a:p>
         </p:txBody>
@@ -8277,13 +8349,13 @@
               </a:lnSpc>
             </a:pPr>
             <a:r>
-              <a:rPr sz="2200" b="1" i="0">
-                <a:solidFill>
-                  <a:srgbClr val="7A4E00"/>
+              <a:rPr sz="2800" b="1" i="0">
+                <a:solidFill>
+                  <a:srgbClr val="004C45"/>
                 </a:solidFill>
                 <a:latin typeface="Georgia"/>
               </a:rPr>
-              <a:t>17</a:t>
+              <a:t>39</a:t>
             </a:r>
           </a:p>
         </p:txBody>
@@ -8322,7 +8394,7 @@
                 </a:solidFill>
                 <a:latin typeface="Arial"/>
               </a:rPr>
-              <a:t>El nombre científico no aguanta el paso del tiempo</a:t>
+              <a:t>Tienen secuencias públicas: su cero SÍ se puede interpretar</a:t>
             </a:r>
           </a:p>
         </p:txBody>
@@ -8336,7 +8408,7 @@
         <p:spPr>
           <a:xfrm>
             <a:off x="6096059" y="2610000"/>
-            <a:ext cx="5232059" cy="503999"/>
+            <a:ext cx="5232059" cy="706800"/>
           </a:xfrm>
           <a:prstGeom prst="rect">
             <a:avLst/>
@@ -8361,7 +8433,7 @@
                 </a:solidFill>
                 <a:latin typeface="Arial"/>
               </a:rPr>
-              <a:t>Inventario propio con identificador estable</a:t>
+              <a:t>Ninguna aparece en una patente</a:t>
             </a:r>
           </a:p>
         </p:txBody>
@@ -8374,8 +8446,8 @@
         </p:nvSpPr>
         <p:spPr>
           <a:xfrm>
-            <a:off x="6096059" y="3132000"/>
-            <a:ext cx="5232059" cy="216000"/>
+            <a:off x="6096059" y="3338400"/>
+            <a:ext cx="5232059" cy="151200"/>
           </a:xfrm>
           <a:prstGeom prst="rect">
             <a:avLst/>
@@ -8396,7 +8468,7 @@
                 </a:solidFill>
                 <a:latin typeface="Arial"/>
               </a:rPr>
-              <a:t>M2 · USD 531.000</a:t>
+              <a:t>ENA · clase PAT · 20 de octubre de 2026</a:t>
             </a:r>
           </a:p>
         </p:txBody>
@@ -8409,7 +8481,7 @@
         </p:nvSpPr>
         <p:spPr>
           <a:xfrm>
-            <a:off x="684000" y="3214800"/>
+            <a:off x="684000" y="3511200"/>
             <a:ext cx="10824119" cy="9525"/>
           </a:xfrm>
           <a:prstGeom prst="rect">
@@ -8453,7 +8525,7 @@
         </p:nvSpPr>
         <p:spPr>
           <a:xfrm>
-            <a:off x="684000" y="3337200"/>
+            <a:off x="684000" y="3583200"/>
             <a:ext cx="1551859" cy="432000"/>
           </a:xfrm>
           <a:prstGeom prst="rect">
@@ -8473,13 +8545,13 @@
               </a:lnSpc>
             </a:pPr>
             <a:r>
-              <a:rPr sz="2200" b="1" i="0">
+              <a:rPr sz="2800" b="1" i="0">
                 <a:solidFill>
                   <a:srgbClr val="7A4E00"/>
                 </a:solidFill>
                 <a:latin typeface="Georgia"/>
               </a:rPr>
-              <a:t>59 %</a:t>
+              <a:t>60</a:t>
             </a:r>
           </a:p>
         </p:txBody>
@@ -8492,7 +8564,7 @@
         </p:nvSpPr>
         <p:spPr>
           <a:xfrm>
-            <a:off x="2415859" y="3337200"/>
+            <a:off x="2415859" y="3583200"/>
             <a:ext cx="3392200" cy="576000"/>
           </a:xfrm>
           <a:prstGeom prst="rect">
@@ -8518,7 +8590,7 @@
                 </a:solidFill>
                 <a:latin typeface="Arial"/>
               </a:rPr>
-              <a:t>Nada obliga a que el origen viaje pegado al dato</a:t>
+              <a:t>No tienen una sola secuencia: no hay nada que buscar</a:t>
             </a:r>
           </a:p>
         </p:txBody>
@@ -8531,8 +8603,8 @@
         </p:nvSpPr>
         <p:spPr>
           <a:xfrm>
-            <a:off x="6096059" y="3294000"/>
-            <a:ext cx="5232059" cy="503999"/>
+            <a:off x="6096059" y="3540000"/>
+            <a:ext cx="5232059" cy="706800"/>
           </a:xfrm>
           <a:prstGeom prst="rect">
             <a:avLst/>
@@ -8557,7 +8629,7 @@
                 </a:solidFill>
                 <a:latin typeface="Arial"/>
               </a:rPr>
-              <a:t>Etiquetado que viaja con el registro</a:t>
+              <a:t>No se puede saber</a:t>
             </a:r>
           </a:p>
         </p:txBody>
@@ -8570,8 +8642,8 @@
         </p:nvSpPr>
         <p:spPr>
           <a:xfrm>
-            <a:off x="6096059" y="3816000"/>
-            <a:ext cx="5232059" cy="216000"/>
+            <a:off x="6096059" y="4268400"/>
+            <a:ext cx="5232059" cy="151200"/>
           </a:xfrm>
           <a:prstGeom prst="rect">
             <a:avLst/>
@@ -8592,7 +8664,7 @@
                 </a:solidFill>
                 <a:latin typeface="Arial"/>
               </a:rPr>
-              <a:t>M1 · USD 288.000</a:t>
+              <a:t>su cero no es interpretable, y hay que decirlo</a:t>
             </a:r>
           </a:p>
         </p:txBody>
@@ -8605,7 +8677,7 @@
         </p:nvSpPr>
         <p:spPr>
           <a:xfrm>
-            <a:off x="684000" y="3898800"/>
+            <a:off x="684000" y="4441200"/>
             <a:ext cx="10824119" cy="9525"/>
           </a:xfrm>
           <a:prstGeom prst="rect">
@@ -8649,7 +8721,7 @@
         </p:nvSpPr>
         <p:spPr>
           <a:xfrm>
-            <a:off x="684000" y="4021200"/>
+            <a:off x="684000" y="4513200"/>
             <a:ext cx="1551859" cy="432000"/>
           </a:xfrm>
           <a:prstGeom prst="rect">
@@ -8669,13 +8741,13 @@
               </a:lnSpc>
             </a:pPr>
             <a:r>
-              <a:rPr sz="2200" b="1" i="0">
-                <a:solidFill>
-                  <a:srgbClr val="7A4E00"/>
+              <a:rPr sz="2800" b="1" i="0">
+                <a:solidFill>
+                  <a:srgbClr val="004C45"/>
                 </a:solidFill>
                 <a:latin typeface="Georgia"/>
               </a:rPr>
-              <a:t>sin aviso</a:t>
+              <a:t>0</a:t>
             </a:r>
           </a:p>
         </p:txBody>
@@ -8688,7 +8760,7 @@
         </p:nvSpPr>
         <p:spPr>
           <a:xfrm>
-            <a:off x="2415859" y="4021200"/>
+            <a:off x="2415859" y="4513200"/>
             <a:ext cx="3392200" cy="576000"/>
           </a:xfrm>
           <a:prstGeom prst="rect">
@@ -8714,7 +8786,7 @@
                 </a:solidFill>
                 <a:latin typeface="Arial"/>
               </a:rPr>
-              <a:t>No existe vigilancia: hay que mirar registro por registro</a:t>
+              <a:t>Patentes halladas sobre las 39 comprobables</a:t>
             </a:r>
           </a:p>
         </p:txBody>
@@ -8727,8 +8799,8 @@
         </p:nvSpPr>
         <p:spPr>
           <a:xfrm>
-            <a:off x="6096059" y="3978000"/>
-            <a:ext cx="5232059" cy="503999"/>
+            <a:off x="6096059" y="4470000"/>
+            <a:ext cx="5232059" cy="706800"/>
           </a:xfrm>
           <a:prstGeom prst="rect">
             <a:avLst/>
@@ -8753,7 +8825,7 @@
                 </a:solidFill>
                 <a:latin typeface="Arial"/>
               </a:rPr>
-              <a:t>Monitoreo comunitario: alerta y anterioridad probatoria</a:t>
+              <a:t>Nadie las ha tocado todavía</a:t>
             </a:r>
           </a:p>
         </p:txBody>
@@ -8766,8 +8838,8 @@
         </p:nvSpPr>
         <p:spPr>
           <a:xfrm>
-            <a:off x="6096059" y="4500000"/>
-            <a:ext cx="5232059" cy="216000"/>
+            <a:off x="6096059" y="5198400"/>
+            <a:ext cx="5232059" cy="151200"/>
           </a:xfrm>
           <a:prstGeom prst="rect">
             <a:avLst/>
@@ -8788,7 +8860,7 @@
                 </a:solidFill>
                 <a:latin typeface="Arial"/>
               </a:rPr>
-              <a:t>M3 · USD 7.090.000</a:t>
+              <a:t>la ausencia de patentes es ausencia de investigación</a:t>
             </a:r>
           </a:p>
         </p:txBody>
@@ -8796,202 +8868,6 @@
       <p:sp>
         <p:nvSpPr>
           <p:cNvPr id="27" name="Rectangle 26"/>
-          <p:cNvSpPr/>
-          <p:nvPr/>
-        </p:nvSpPr>
-        <p:spPr>
-          <a:xfrm>
-            <a:off x="684000" y="4582800"/>
-            <a:ext cx="10824119" cy="9525"/>
-          </a:xfrm>
-          <a:prstGeom prst="rect">
-            <a:avLst/>
-          </a:prstGeom>
-          <a:solidFill>
-            <a:srgbClr val="C2C8C5"/>
-          </a:solidFill>
-          <a:ln>
-            <a:noFill/>
-          </a:ln>
-          <a:effectLst/>
-        </p:spPr>
-        <p:style>
-          <a:lnRef idx="1">
-            <a:schemeClr val="accent1"/>
-          </a:lnRef>
-          <a:fillRef idx="3">
-            <a:schemeClr val="accent1"/>
-          </a:fillRef>
-          <a:effectRef idx="2">
-            <a:schemeClr val="accent1"/>
-          </a:effectRef>
-          <a:fontRef idx="minor">
-            <a:schemeClr val="lt1"/>
-          </a:fontRef>
-        </p:style>
-        <p:txBody>
-          <a:bodyPr rtlCol="0" anchor="ctr"/>
-          <a:lstStyle/>
-          <a:p>
-            <a:pPr algn="ctr"/>
-          </a:p>
-        </p:txBody>
-      </p:sp>
-      <p:sp>
-        <p:nvSpPr>
-          <p:cNvPr id="28" name="TextBox 27"/>
-          <p:cNvSpPr txBox="1"/>
-          <p:nvPr/>
-        </p:nvSpPr>
-        <p:spPr>
-          <a:xfrm>
-            <a:off x="684000" y="4705200"/>
-            <a:ext cx="1551859" cy="432000"/>
-          </a:xfrm>
-          <a:prstGeom prst="rect">
-            <a:avLst/>
-          </a:prstGeom>
-          <a:noFill/>
-        </p:spPr>
-        <p:txBody>
-          <a:bodyPr wrap="square" lIns="0" rIns="0" tIns="0" bIns="0" anchor="t">
-            <a:spAutoFit/>
-          </a:bodyPr>
-          <a:lstStyle/>
-          <a:p>
-            <a:pPr algn="l">
-              <a:lnSpc>
-                <a:spcPct val="95000"/>
-              </a:lnSpc>
-            </a:pPr>
-            <a:r>
-              <a:rPr sz="2200" b="1" i="0">
-                <a:solidFill>
-                  <a:srgbClr val="7A4E00"/>
-                </a:solidFill>
-                <a:latin typeface="Georgia"/>
-              </a:rPr>
-              <a:t>57</a:t>
-            </a:r>
-          </a:p>
-        </p:txBody>
-      </p:sp>
-      <p:sp>
-        <p:nvSpPr>
-          <p:cNvPr id="29" name="TextBox 28"/>
-          <p:cNvSpPr txBox="1"/>
-          <p:nvPr/>
-        </p:nvSpPr>
-        <p:spPr>
-          <a:xfrm>
-            <a:off x="2415859" y="4705200"/>
-            <a:ext cx="3392200" cy="576000"/>
-          </a:xfrm>
-          <a:prstGeom prst="rect">
-            <a:avLst/>
-          </a:prstGeom>
-          <a:noFill/>
-        </p:spPr>
-        <p:txBody>
-          <a:bodyPr wrap="square" lIns="0" rIns="0" tIns="0" bIns="0" anchor="t">
-            <a:spAutoFit/>
-          </a:bodyPr>
-          <a:lstStyle/>
-          <a:p>
-            <a:pPr algn="l">
-              <a:lnSpc>
-                <a:spcPct val="120000"/>
-              </a:lnSpc>
-            </a:pPr>
-            <a:r>
-              <a:rPr sz="1500" b="0" i="0">
-                <a:solidFill>
-                  <a:srgbClr val="04110F"/>
-                </a:solidFill>
-                <a:latin typeface="Arial"/>
-              </a:rPr>
-              <a:t>La ventana sigue abierta, y se cierra sola</a:t>
-            </a:r>
-          </a:p>
-        </p:txBody>
-      </p:sp>
-      <p:sp>
-        <p:nvSpPr>
-          <p:cNvPr id="30" name="TextBox 29"/>
-          <p:cNvSpPr txBox="1"/>
-          <p:nvPr/>
-        </p:nvSpPr>
-        <p:spPr>
-          <a:xfrm>
-            <a:off x="6096059" y="4662000"/>
-            <a:ext cx="5232059" cy="503999"/>
-          </a:xfrm>
-          <a:prstGeom prst="rect">
-            <a:avLst/>
-          </a:prstGeom>
-          <a:noFill/>
-        </p:spPr>
-        <p:txBody>
-          <a:bodyPr wrap="square" lIns="0" rIns="0" tIns="0" bIns="0" anchor="t">
-            <a:spAutoFit/>
-          </a:bodyPr>
-          <a:lstStyle/>
-          <a:p>
-            <a:pPr algn="l">
-              <a:lnSpc>
-                <a:spcPct val="115000"/>
-              </a:lnSpc>
-            </a:pPr>
-            <a:r>
-              <a:rPr sz="1600" b="1" i="0">
-                <a:solidFill>
-                  <a:srgbClr val="004C45"/>
-                </a:solidFill>
-                <a:latin typeface="Arial"/>
-              </a:rPr>
-              <a:t>Banco genético propio: llegar primero</a:t>
-            </a:r>
-          </a:p>
-        </p:txBody>
-      </p:sp>
-      <p:sp>
-        <p:nvSpPr>
-          <p:cNvPr id="31" name="TextBox 30"/>
-          <p:cNvSpPr txBox="1"/>
-          <p:nvPr/>
-        </p:nvSpPr>
-        <p:spPr>
-          <a:xfrm>
-            <a:off x="6096059" y="5184000"/>
-            <a:ext cx="5232059" cy="216000"/>
-          </a:xfrm>
-          <a:prstGeom prst="rect">
-            <a:avLst/>
-          </a:prstGeom>
-          <a:noFill/>
-        </p:spPr>
-        <p:txBody>
-          <a:bodyPr wrap="square" lIns="0" rIns="0" tIns="0" bIns="0" anchor="t">
-            <a:spAutoFit/>
-          </a:bodyPr>
-          <a:lstStyle/>
-          <a:p>
-            <a:pPr algn="l"/>
-            <a:r>
-              <a:rPr sz="1200" b="0" i="0">
-                <a:solidFill>
-                  <a:srgbClr val="555E5B"/>
-                </a:solidFill>
-                <a:latin typeface="Arial"/>
-              </a:rPr>
-              <a:t>M4 · USD 1.268.000</a:t>
-            </a:r>
-          </a:p>
-        </p:txBody>
-      </p:sp>
-      <p:sp>
-        <p:nvSpPr>
-          <p:cNvPr id="32" name="Rectangle 31"/>
           <p:cNvSpPr/>
           <p:nvPr/>
         </p:nvSpPr>
@@ -9035,7 +8911,7 @@
       </p:sp>
       <p:sp>
         <p:nvSpPr>
-          <p:cNvPr id="33" name="TextBox 32"/>
+          <p:cNvPr id="28" name="TextBox 27"/>
           <p:cNvSpPr txBox="1"/>
           <p:nvPr/>
         </p:nvSpPr>
@@ -9067,14 +8943,14 @@
                 </a:solidFill>
                 <a:latin typeface="Arial"/>
               </a:rPr>
-              <a:t>Y el monitoreo no es un principio: es la prueba. Las patentes de la cúrcuma, del neem y del frijol se tumbaron por anterioridad documentada, no por falta de divulgación de origen. Un pueblo que registra sistemáticamente está fabricando el único argumento que ha ganado.</a:t>
-            </a:r>
-          </a:p>
-        </p:txBody>
-      </p:sp>
-      <p:sp>
-        <p:nvSpPr>
-          <p:cNvPr id="34" name="TextBox 33"/>
+              <a:t>Son 70.526.111 secuencias divulgadas en patentes, más que las ordinarias, y ninguna declara país de origen: ni de Colombia ni de ningún otro país. Nuestra especie más secuenciada tiene 137; la papa cultivada, 418.482. No decimos que nos lo quitaron: decimos que el sistema está hecho para que nadie pueda saberlo.</a:t>
+            </a:r>
+          </a:p>
+        </p:txBody>
+      </p:sp>
+      <p:sp>
+        <p:nvSpPr>
+          <p:cNvPr id="29" name="TextBox 28"/>
           <p:cNvSpPr txBox="1"/>
           <p:nvPr/>
         </p:nvSpPr>
@@ -9102,7 +8978,7 @@
                 </a:solidFill>
                 <a:latin typeface="Arial"/>
               </a:rPr>
-              <a:t>Fuente: ONIC, 2026.</a:t>
+              <a:t>Figura 11. European Nucleotide Archive, clase de datos PAT, consulta del 20 de octubre de 2026. Fuente: ONIC, 2026.</a:t>
             </a:r>
           </a:p>
         </p:txBody>
@@ -9199,7 +9075,1281 @@
                 </a:solidFill>
                 <a:latin typeface="Arial"/>
               </a:rPr>
-              <a:t>12 · LO QUE DEJAMOS AQUÍ</a:t>
+              <a:t>12 · QUÉ HACEMOS CON ESTO</a:t>
+            </a:r>
+          </a:p>
+        </p:txBody>
+      </p:sp>
+      <p:pic>
+        <p:nvPicPr>
+          <p:cNvPr id="4" name="Picture 3" descr="logo_smt.png"/>
+          <p:cNvPicPr>
+            <a:picLocks noChangeAspect="1"/>
+          </p:cNvPicPr>
+          <p:nvPr/>
+        </p:nvPicPr>
+        <p:blipFill>
+          <a:blip r:embed="rId2"/>
+          <a:stretch>
+            <a:fillRect/>
+          </a:stretch>
+        </p:blipFill>
+        <p:spPr>
+          <a:xfrm>
+            <a:off x="10875518" y="396000"/>
+            <a:ext cx="632601" cy="342000"/>
+          </a:xfrm>
+          <a:prstGeom prst="rect">
+            <a:avLst/>
+          </a:prstGeom>
+        </p:spPr>
+      </p:pic>
+      <p:pic>
+        <p:nvPicPr>
+          <p:cNvPr id="5" name="Picture 4" descr="logo_onic.png"/>
+          <p:cNvPicPr>
+            <a:picLocks noChangeAspect="1"/>
+          </p:cNvPicPr>
+          <p:nvPr/>
+        </p:nvPicPr>
+        <p:blipFill>
+          <a:blip r:embed="rId3"/>
+          <a:stretch>
+            <a:fillRect/>
+          </a:stretch>
+        </p:blipFill>
+        <p:spPr>
+          <a:xfrm>
+            <a:off x="10168126" y="342000"/>
+            <a:ext cx="455393" cy="450000"/>
+          </a:xfrm>
+          <a:prstGeom prst="rect">
+            <a:avLst/>
+          </a:prstGeom>
+        </p:spPr>
+      </p:pic>
+      <p:sp>
+        <p:nvSpPr>
+          <p:cNvPr id="6" name="Rectangle 5"/>
+          <p:cNvSpPr/>
+          <p:nvPr/>
+        </p:nvSpPr>
+        <p:spPr>
+          <a:xfrm>
+            <a:off x="684000" y="917999"/>
+            <a:ext cx="10824119" cy="19050"/>
+          </a:xfrm>
+          <a:prstGeom prst="rect">
+            <a:avLst/>
+          </a:prstGeom>
+          <a:solidFill>
+            <a:srgbClr val="004C45"/>
+          </a:solidFill>
+          <a:ln>
+            <a:noFill/>
+          </a:ln>
+          <a:effectLst/>
+        </p:spPr>
+        <p:style>
+          <a:lnRef idx="1">
+            <a:schemeClr val="accent1"/>
+          </a:lnRef>
+          <a:fillRef idx="3">
+            <a:schemeClr val="accent1"/>
+          </a:fillRef>
+          <a:effectRef idx="2">
+            <a:schemeClr val="accent1"/>
+          </a:effectRef>
+          <a:fontRef idx="minor">
+            <a:schemeClr val="lt1"/>
+          </a:fontRef>
+        </p:style>
+        <p:txBody>
+          <a:bodyPr rtlCol="0" anchor="ctr"/>
+          <a:lstStyle/>
+          <a:p>
+            <a:pPr algn="ctr"/>
+          </a:p>
+        </p:txBody>
+      </p:sp>
+      <p:sp>
+        <p:nvSpPr>
+          <p:cNvPr id="7" name="TextBox 6"/>
+          <p:cNvSpPr txBox="1"/>
+          <p:nvPr/>
+        </p:nvSpPr>
+        <p:spPr>
+          <a:xfrm>
+            <a:off x="684000" y="1188000"/>
+            <a:ext cx="4762612" cy="864000"/>
+          </a:xfrm>
+          <a:prstGeom prst="rect">
+            <a:avLst/>
+          </a:prstGeom>
+          <a:noFill/>
+        </p:spPr>
+        <p:txBody>
+          <a:bodyPr wrap="square" lIns="0" rIns="0" tIns="0" bIns="0" anchor="t">
+            <a:spAutoFit/>
+          </a:bodyPr>
+          <a:lstStyle/>
+          <a:p>
+            <a:pPr algn="l">
+              <a:lnSpc>
+                <a:spcPct val="100000"/>
+              </a:lnSpc>
+            </a:pPr>
+            <a:r>
+              <a:rPr sz="3000" b="1" i="0">
+                <a:solidFill>
+                  <a:srgbClr val="004C45"/>
+                </a:solidFill>
+                <a:latin typeface="Georgia"/>
+              </a:rPr>
+              <a:t>Cada ceguera tiene su respuesta.</a:t>
+            </a:r>
+          </a:p>
+        </p:txBody>
+      </p:sp>
+      <p:sp>
+        <p:nvSpPr>
+          <p:cNvPr id="8" name="TextBox 7"/>
+          <p:cNvSpPr txBox="1"/>
+          <p:nvPr/>
+        </p:nvSpPr>
+        <p:spPr>
+          <a:xfrm>
+            <a:off x="5879577" y="1206000"/>
+            <a:ext cx="5628541" cy="720000"/>
+          </a:xfrm>
+          <a:prstGeom prst="rect">
+            <a:avLst/>
+          </a:prstGeom>
+          <a:noFill/>
+        </p:spPr>
+        <p:txBody>
+          <a:bodyPr wrap="square" lIns="0" rIns="0" tIns="0" bIns="0" anchor="t">
+            <a:spAutoFit/>
+          </a:bodyPr>
+          <a:lstStyle/>
+          <a:p>
+            <a:pPr algn="l">
+              <a:lnSpc>
+                <a:spcPct val="130000"/>
+              </a:lnSpc>
+            </a:pPr>
+            <a:r>
+              <a:rPr sz="1500" b="0" i="0">
+                <a:solidFill>
+                  <a:srgbClr val="04110F"/>
+                </a:solidFill>
+                <a:latin typeface="Arial"/>
+              </a:rPr>
+              <a:t>No hubo que inventar el vínculo: cada cosa que medimos justifica, por sí sola, una de las cuatro líneas que la ONIC viene proponiendo.</a:t>
+            </a:r>
+          </a:p>
+        </p:txBody>
+      </p:sp>
+      <p:sp>
+        <p:nvSpPr>
+          <p:cNvPr id="9" name="TextBox 8"/>
+          <p:cNvSpPr txBox="1"/>
+          <p:nvPr/>
+        </p:nvSpPr>
+        <p:spPr>
+          <a:xfrm>
+            <a:off x="684000" y="2232000"/>
+            <a:ext cx="1551859" cy="251999"/>
+          </a:xfrm>
+          <a:prstGeom prst="rect">
+            <a:avLst/>
+          </a:prstGeom>
+          <a:noFill/>
+        </p:spPr>
+        <p:txBody>
+          <a:bodyPr wrap="square" lIns="0" rIns="0" tIns="0" bIns="0" anchor="t">
+            <a:spAutoFit/>
+          </a:bodyPr>
+          <a:lstStyle/>
+          <a:p>
+            <a:pPr algn="l"/>
+            <a:r>
+              <a:rPr sz="1300" b="1" i="0">
+                <a:solidFill>
+                  <a:srgbClr val="004C45"/>
+                </a:solidFill>
+                <a:latin typeface="Arial"/>
+              </a:rPr>
+              <a:t>LO MEDIDO</a:t>
+            </a:r>
+          </a:p>
+        </p:txBody>
+      </p:sp>
+      <p:sp>
+        <p:nvSpPr>
+          <p:cNvPr id="10" name="TextBox 9"/>
+          <p:cNvSpPr txBox="1"/>
+          <p:nvPr/>
+        </p:nvSpPr>
+        <p:spPr>
+          <a:xfrm>
+            <a:off x="2415859" y="2232000"/>
+            <a:ext cx="3500200" cy="251999"/>
+          </a:xfrm>
+          <a:prstGeom prst="rect">
+            <a:avLst/>
+          </a:prstGeom>
+          <a:noFill/>
+        </p:spPr>
+        <p:txBody>
+          <a:bodyPr wrap="square" lIns="0" rIns="0" tIns="0" bIns="0" anchor="t">
+            <a:spAutoFit/>
+          </a:bodyPr>
+          <a:lstStyle/>
+          <a:p>
+            <a:pPr algn="l"/>
+            <a:r>
+              <a:rPr sz="1300" b="1" i="0">
+                <a:solidFill>
+                  <a:srgbClr val="004C45"/>
+                </a:solidFill>
+                <a:latin typeface="Arial"/>
+              </a:rPr>
+              <a:t>POR QUÉ FALLA</a:t>
+            </a:r>
+          </a:p>
+        </p:txBody>
+      </p:sp>
+      <p:sp>
+        <p:nvSpPr>
+          <p:cNvPr id="11" name="TextBox 10"/>
+          <p:cNvSpPr txBox="1"/>
+          <p:nvPr/>
+        </p:nvSpPr>
+        <p:spPr>
+          <a:xfrm>
+            <a:off x="6096059" y="2232000"/>
+            <a:ext cx="5232059" cy="251999"/>
+          </a:xfrm>
+          <a:prstGeom prst="rect">
+            <a:avLst/>
+          </a:prstGeom>
+          <a:noFill/>
+        </p:spPr>
+        <p:txBody>
+          <a:bodyPr wrap="square" lIns="0" rIns="0" tIns="0" bIns="0" anchor="t">
+            <a:spAutoFit/>
+          </a:bodyPr>
+          <a:lstStyle/>
+          <a:p>
+            <a:pPr algn="l"/>
+            <a:r>
+              <a:rPr sz="1300" b="1" i="0">
+                <a:solidFill>
+                  <a:srgbClr val="004C45"/>
+                </a:solidFill>
+                <a:latin typeface="Arial"/>
+              </a:rPr>
+              <a:t>LA RESPUESTA</a:t>
+            </a:r>
+          </a:p>
+        </p:txBody>
+      </p:sp>
+      <p:sp>
+        <p:nvSpPr>
+          <p:cNvPr id="12" name="Rectangle 11"/>
+          <p:cNvSpPr/>
+          <p:nvPr/>
+        </p:nvSpPr>
+        <p:spPr>
+          <a:xfrm>
+            <a:off x="684000" y="2520000"/>
+            <a:ext cx="10824119" cy="19050"/>
+          </a:xfrm>
+          <a:prstGeom prst="rect">
+            <a:avLst/>
+          </a:prstGeom>
+          <a:solidFill>
+            <a:srgbClr val="004C45"/>
+          </a:solidFill>
+          <a:ln>
+            <a:noFill/>
+          </a:ln>
+          <a:effectLst/>
+        </p:spPr>
+        <p:style>
+          <a:lnRef idx="1">
+            <a:schemeClr val="accent1"/>
+          </a:lnRef>
+          <a:fillRef idx="3">
+            <a:schemeClr val="accent1"/>
+          </a:fillRef>
+          <a:effectRef idx="2">
+            <a:schemeClr val="accent1"/>
+          </a:effectRef>
+          <a:fontRef idx="minor">
+            <a:schemeClr val="lt1"/>
+          </a:fontRef>
+        </p:style>
+        <p:txBody>
+          <a:bodyPr rtlCol="0" anchor="ctr"/>
+          <a:lstStyle/>
+          <a:p>
+            <a:pPr algn="ctr"/>
+          </a:p>
+        </p:txBody>
+      </p:sp>
+      <p:sp>
+        <p:nvSpPr>
+          <p:cNvPr id="13" name="TextBox 12"/>
+          <p:cNvSpPr txBox="1"/>
+          <p:nvPr/>
+        </p:nvSpPr>
+        <p:spPr>
+          <a:xfrm>
+            <a:off x="684000" y="2653200"/>
+            <a:ext cx="1551859" cy="432000"/>
+          </a:xfrm>
+          <a:prstGeom prst="rect">
+            <a:avLst/>
+          </a:prstGeom>
+          <a:noFill/>
+        </p:spPr>
+        <p:txBody>
+          <a:bodyPr wrap="square" lIns="0" rIns="0" tIns="0" bIns="0" anchor="t">
+            <a:spAutoFit/>
+          </a:bodyPr>
+          <a:lstStyle/>
+          <a:p>
+            <a:pPr algn="l">
+              <a:lnSpc>
+                <a:spcPct val="95000"/>
+              </a:lnSpc>
+            </a:pPr>
+            <a:r>
+              <a:rPr sz="2200" b="1" i="0">
+                <a:solidFill>
+                  <a:srgbClr val="7A4E00"/>
+                </a:solidFill>
+                <a:latin typeface="Georgia"/>
+              </a:rPr>
+              <a:t>17</a:t>
+            </a:r>
+          </a:p>
+        </p:txBody>
+      </p:sp>
+      <p:sp>
+        <p:nvSpPr>
+          <p:cNvPr id="14" name="TextBox 13"/>
+          <p:cNvSpPr txBox="1"/>
+          <p:nvPr/>
+        </p:nvSpPr>
+        <p:spPr>
+          <a:xfrm>
+            <a:off x="2415859" y="2653200"/>
+            <a:ext cx="3392200" cy="576000"/>
+          </a:xfrm>
+          <a:prstGeom prst="rect">
+            <a:avLst/>
+          </a:prstGeom>
+          <a:noFill/>
+        </p:spPr>
+        <p:txBody>
+          <a:bodyPr wrap="square" lIns="0" rIns="0" tIns="0" bIns="0" anchor="t">
+            <a:spAutoFit/>
+          </a:bodyPr>
+          <a:lstStyle/>
+          <a:p>
+            <a:pPr algn="l">
+              <a:lnSpc>
+                <a:spcPct val="120000"/>
+              </a:lnSpc>
+            </a:pPr>
+            <a:r>
+              <a:rPr sz="1500" b="0" i="0">
+                <a:solidFill>
+                  <a:srgbClr val="04110F"/>
+                </a:solidFill>
+                <a:latin typeface="Arial"/>
+              </a:rPr>
+              <a:t>El nombre científico no aguanta el paso del tiempo</a:t>
+            </a:r>
+          </a:p>
+        </p:txBody>
+      </p:sp>
+      <p:sp>
+        <p:nvSpPr>
+          <p:cNvPr id="15" name="TextBox 14"/>
+          <p:cNvSpPr txBox="1"/>
+          <p:nvPr/>
+        </p:nvSpPr>
+        <p:spPr>
+          <a:xfrm>
+            <a:off x="6096059" y="2610000"/>
+            <a:ext cx="5232059" cy="474300"/>
+          </a:xfrm>
+          <a:prstGeom prst="rect">
+            <a:avLst/>
+          </a:prstGeom>
+          <a:noFill/>
+        </p:spPr>
+        <p:txBody>
+          <a:bodyPr wrap="square" lIns="0" rIns="0" tIns="0" bIns="0" anchor="t">
+            <a:spAutoFit/>
+          </a:bodyPr>
+          <a:lstStyle/>
+          <a:p>
+            <a:pPr algn="l">
+              <a:lnSpc>
+                <a:spcPct val="115000"/>
+              </a:lnSpc>
+            </a:pPr>
+            <a:r>
+              <a:rPr sz="1600" b="1" i="0">
+                <a:solidFill>
+                  <a:srgbClr val="004C45"/>
+                </a:solidFill>
+                <a:latin typeface="Arial"/>
+              </a:rPr>
+              <a:t>Inventario propio con identificador estable</a:t>
+            </a:r>
+          </a:p>
+        </p:txBody>
+      </p:sp>
+      <p:sp>
+        <p:nvSpPr>
+          <p:cNvPr id="16" name="TextBox 15"/>
+          <p:cNvSpPr txBox="1"/>
+          <p:nvPr/>
+        </p:nvSpPr>
+        <p:spPr>
+          <a:xfrm>
+            <a:off x="6096059" y="3105900"/>
+            <a:ext cx="5232059" cy="151200"/>
+          </a:xfrm>
+          <a:prstGeom prst="rect">
+            <a:avLst/>
+          </a:prstGeom>
+          <a:noFill/>
+        </p:spPr>
+        <p:txBody>
+          <a:bodyPr wrap="square" lIns="0" rIns="0" tIns="0" bIns="0" anchor="t">
+            <a:spAutoFit/>
+          </a:bodyPr>
+          <a:lstStyle/>
+          <a:p>
+            <a:pPr algn="l"/>
+            <a:r>
+              <a:rPr sz="1200" b="0" i="0">
+                <a:solidFill>
+                  <a:srgbClr val="555E5B"/>
+                </a:solidFill>
+                <a:latin typeface="Arial"/>
+              </a:rPr>
+              <a:t>M2 · USD 531.000</a:t>
+            </a:r>
+          </a:p>
+        </p:txBody>
+      </p:sp>
+      <p:sp>
+        <p:nvSpPr>
+          <p:cNvPr id="17" name="Rectangle 16"/>
+          <p:cNvSpPr/>
+          <p:nvPr/>
+        </p:nvSpPr>
+        <p:spPr>
+          <a:xfrm>
+            <a:off x="684000" y="3278700"/>
+            <a:ext cx="10824119" cy="9525"/>
+          </a:xfrm>
+          <a:prstGeom prst="rect">
+            <a:avLst/>
+          </a:prstGeom>
+          <a:solidFill>
+            <a:srgbClr val="C2C8C5"/>
+          </a:solidFill>
+          <a:ln>
+            <a:noFill/>
+          </a:ln>
+          <a:effectLst/>
+        </p:spPr>
+        <p:style>
+          <a:lnRef idx="1">
+            <a:schemeClr val="accent1"/>
+          </a:lnRef>
+          <a:fillRef idx="3">
+            <a:schemeClr val="accent1"/>
+          </a:fillRef>
+          <a:effectRef idx="2">
+            <a:schemeClr val="accent1"/>
+          </a:effectRef>
+          <a:fontRef idx="minor">
+            <a:schemeClr val="lt1"/>
+          </a:fontRef>
+        </p:style>
+        <p:txBody>
+          <a:bodyPr rtlCol="0" anchor="ctr"/>
+          <a:lstStyle/>
+          <a:p>
+            <a:pPr algn="ctr"/>
+          </a:p>
+        </p:txBody>
+      </p:sp>
+      <p:sp>
+        <p:nvSpPr>
+          <p:cNvPr id="18" name="TextBox 17"/>
+          <p:cNvSpPr txBox="1"/>
+          <p:nvPr/>
+        </p:nvSpPr>
+        <p:spPr>
+          <a:xfrm>
+            <a:off x="684000" y="3350700"/>
+            <a:ext cx="1551859" cy="432000"/>
+          </a:xfrm>
+          <a:prstGeom prst="rect">
+            <a:avLst/>
+          </a:prstGeom>
+          <a:noFill/>
+        </p:spPr>
+        <p:txBody>
+          <a:bodyPr wrap="square" lIns="0" rIns="0" tIns="0" bIns="0" anchor="t">
+            <a:spAutoFit/>
+          </a:bodyPr>
+          <a:lstStyle/>
+          <a:p>
+            <a:pPr algn="l">
+              <a:lnSpc>
+                <a:spcPct val="95000"/>
+              </a:lnSpc>
+            </a:pPr>
+            <a:r>
+              <a:rPr sz="2200" b="1" i="0">
+                <a:solidFill>
+                  <a:srgbClr val="7A4E00"/>
+                </a:solidFill>
+                <a:latin typeface="Georgia"/>
+              </a:rPr>
+              <a:t>59 %</a:t>
+            </a:r>
+          </a:p>
+        </p:txBody>
+      </p:sp>
+      <p:sp>
+        <p:nvSpPr>
+          <p:cNvPr id="19" name="TextBox 18"/>
+          <p:cNvSpPr txBox="1"/>
+          <p:nvPr/>
+        </p:nvSpPr>
+        <p:spPr>
+          <a:xfrm>
+            <a:off x="2415859" y="3350700"/>
+            <a:ext cx="3392200" cy="576000"/>
+          </a:xfrm>
+          <a:prstGeom prst="rect">
+            <a:avLst/>
+          </a:prstGeom>
+          <a:noFill/>
+        </p:spPr>
+        <p:txBody>
+          <a:bodyPr wrap="square" lIns="0" rIns="0" tIns="0" bIns="0" anchor="t">
+            <a:spAutoFit/>
+          </a:bodyPr>
+          <a:lstStyle/>
+          <a:p>
+            <a:pPr algn="l">
+              <a:lnSpc>
+                <a:spcPct val="120000"/>
+              </a:lnSpc>
+            </a:pPr>
+            <a:r>
+              <a:rPr sz="1500" b="0" i="0">
+                <a:solidFill>
+                  <a:srgbClr val="04110F"/>
+                </a:solidFill>
+                <a:latin typeface="Arial"/>
+              </a:rPr>
+              <a:t>Nada obliga a que el origen viaje pegado al dato</a:t>
+            </a:r>
+          </a:p>
+        </p:txBody>
+      </p:sp>
+      <p:sp>
+        <p:nvSpPr>
+          <p:cNvPr id="20" name="TextBox 19"/>
+          <p:cNvSpPr txBox="1"/>
+          <p:nvPr/>
+        </p:nvSpPr>
+        <p:spPr>
+          <a:xfrm>
+            <a:off x="6096059" y="3307500"/>
+            <a:ext cx="5232059" cy="474300"/>
+          </a:xfrm>
+          <a:prstGeom prst="rect">
+            <a:avLst/>
+          </a:prstGeom>
+          <a:noFill/>
+        </p:spPr>
+        <p:txBody>
+          <a:bodyPr wrap="square" lIns="0" rIns="0" tIns="0" bIns="0" anchor="t">
+            <a:spAutoFit/>
+          </a:bodyPr>
+          <a:lstStyle/>
+          <a:p>
+            <a:pPr algn="l">
+              <a:lnSpc>
+                <a:spcPct val="115000"/>
+              </a:lnSpc>
+            </a:pPr>
+            <a:r>
+              <a:rPr sz="1600" b="1" i="0">
+                <a:solidFill>
+                  <a:srgbClr val="004C45"/>
+                </a:solidFill>
+                <a:latin typeface="Arial"/>
+              </a:rPr>
+              <a:t>Etiquetado que viaja con el registro</a:t>
+            </a:r>
+          </a:p>
+        </p:txBody>
+      </p:sp>
+      <p:sp>
+        <p:nvSpPr>
+          <p:cNvPr id="21" name="TextBox 20"/>
+          <p:cNvSpPr txBox="1"/>
+          <p:nvPr/>
+        </p:nvSpPr>
+        <p:spPr>
+          <a:xfrm>
+            <a:off x="6096059" y="3803400"/>
+            <a:ext cx="5232059" cy="151200"/>
+          </a:xfrm>
+          <a:prstGeom prst="rect">
+            <a:avLst/>
+          </a:prstGeom>
+          <a:noFill/>
+        </p:spPr>
+        <p:txBody>
+          <a:bodyPr wrap="square" lIns="0" rIns="0" tIns="0" bIns="0" anchor="t">
+            <a:spAutoFit/>
+          </a:bodyPr>
+          <a:lstStyle/>
+          <a:p>
+            <a:pPr algn="l"/>
+            <a:r>
+              <a:rPr sz="1200" b="0" i="0">
+                <a:solidFill>
+                  <a:srgbClr val="555E5B"/>
+                </a:solidFill>
+                <a:latin typeface="Arial"/>
+              </a:rPr>
+              <a:t>M1 · USD 288.000</a:t>
+            </a:r>
+          </a:p>
+        </p:txBody>
+      </p:sp>
+      <p:sp>
+        <p:nvSpPr>
+          <p:cNvPr id="22" name="Rectangle 21"/>
+          <p:cNvSpPr/>
+          <p:nvPr/>
+        </p:nvSpPr>
+        <p:spPr>
+          <a:xfrm>
+            <a:off x="684000" y="3976200"/>
+            <a:ext cx="10824119" cy="9525"/>
+          </a:xfrm>
+          <a:prstGeom prst="rect">
+            <a:avLst/>
+          </a:prstGeom>
+          <a:solidFill>
+            <a:srgbClr val="C2C8C5"/>
+          </a:solidFill>
+          <a:ln>
+            <a:noFill/>
+          </a:ln>
+          <a:effectLst/>
+        </p:spPr>
+        <p:style>
+          <a:lnRef idx="1">
+            <a:schemeClr val="accent1"/>
+          </a:lnRef>
+          <a:fillRef idx="3">
+            <a:schemeClr val="accent1"/>
+          </a:fillRef>
+          <a:effectRef idx="2">
+            <a:schemeClr val="accent1"/>
+          </a:effectRef>
+          <a:fontRef idx="minor">
+            <a:schemeClr val="lt1"/>
+          </a:fontRef>
+        </p:style>
+        <p:txBody>
+          <a:bodyPr rtlCol="0" anchor="ctr"/>
+          <a:lstStyle/>
+          <a:p>
+            <a:pPr algn="ctr"/>
+          </a:p>
+        </p:txBody>
+      </p:sp>
+      <p:sp>
+        <p:nvSpPr>
+          <p:cNvPr id="23" name="TextBox 22"/>
+          <p:cNvSpPr txBox="1"/>
+          <p:nvPr/>
+        </p:nvSpPr>
+        <p:spPr>
+          <a:xfrm>
+            <a:off x="684000" y="4048200"/>
+            <a:ext cx="1551859" cy="432000"/>
+          </a:xfrm>
+          <a:prstGeom prst="rect">
+            <a:avLst/>
+          </a:prstGeom>
+          <a:noFill/>
+        </p:spPr>
+        <p:txBody>
+          <a:bodyPr wrap="square" lIns="0" rIns="0" tIns="0" bIns="0" anchor="t">
+            <a:spAutoFit/>
+          </a:bodyPr>
+          <a:lstStyle/>
+          <a:p>
+            <a:pPr algn="l">
+              <a:lnSpc>
+                <a:spcPct val="95000"/>
+              </a:lnSpc>
+            </a:pPr>
+            <a:r>
+              <a:rPr sz="2200" b="1" i="0">
+                <a:solidFill>
+                  <a:srgbClr val="7A4E00"/>
+                </a:solidFill>
+                <a:latin typeface="Georgia"/>
+              </a:rPr>
+              <a:t>sin aviso</a:t>
+            </a:r>
+          </a:p>
+        </p:txBody>
+      </p:sp>
+      <p:sp>
+        <p:nvSpPr>
+          <p:cNvPr id="24" name="TextBox 23"/>
+          <p:cNvSpPr txBox="1"/>
+          <p:nvPr/>
+        </p:nvSpPr>
+        <p:spPr>
+          <a:xfrm>
+            <a:off x="2415859" y="4048200"/>
+            <a:ext cx="3392200" cy="576000"/>
+          </a:xfrm>
+          <a:prstGeom prst="rect">
+            <a:avLst/>
+          </a:prstGeom>
+          <a:noFill/>
+        </p:spPr>
+        <p:txBody>
+          <a:bodyPr wrap="square" lIns="0" rIns="0" tIns="0" bIns="0" anchor="t">
+            <a:spAutoFit/>
+          </a:bodyPr>
+          <a:lstStyle/>
+          <a:p>
+            <a:pPr algn="l">
+              <a:lnSpc>
+                <a:spcPct val="120000"/>
+              </a:lnSpc>
+            </a:pPr>
+            <a:r>
+              <a:rPr sz="1500" b="0" i="0">
+                <a:solidFill>
+                  <a:srgbClr val="04110F"/>
+                </a:solidFill>
+                <a:latin typeface="Arial"/>
+              </a:rPr>
+              <a:t>No existe vigilancia: hay que mirar registro por registro</a:t>
+            </a:r>
+          </a:p>
+        </p:txBody>
+      </p:sp>
+      <p:sp>
+        <p:nvSpPr>
+          <p:cNvPr id="25" name="TextBox 24"/>
+          <p:cNvSpPr txBox="1"/>
+          <p:nvPr/>
+        </p:nvSpPr>
+        <p:spPr>
+          <a:xfrm>
+            <a:off x="6096059" y="4005000"/>
+            <a:ext cx="5232059" cy="474300"/>
+          </a:xfrm>
+          <a:prstGeom prst="rect">
+            <a:avLst/>
+          </a:prstGeom>
+          <a:noFill/>
+        </p:spPr>
+        <p:txBody>
+          <a:bodyPr wrap="square" lIns="0" rIns="0" tIns="0" bIns="0" anchor="t">
+            <a:spAutoFit/>
+          </a:bodyPr>
+          <a:lstStyle/>
+          <a:p>
+            <a:pPr algn="l">
+              <a:lnSpc>
+                <a:spcPct val="115000"/>
+              </a:lnSpc>
+            </a:pPr>
+            <a:r>
+              <a:rPr sz="1600" b="1" i="0">
+                <a:solidFill>
+                  <a:srgbClr val="004C45"/>
+                </a:solidFill>
+                <a:latin typeface="Arial"/>
+              </a:rPr>
+              <a:t>Monitoreo comunitario: alerta y anterioridad probatoria</a:t>
+            </a:r>
+          </a:p>
+        </p:txBody>
+      </p:sp>
+      <p:sp>
+        <p:nvSpPr>
+          <p:cNvPr id="26" name="TextBox 25"/>
+          <p:cNvSpPr txBox="1"/>
+          <p:nvPr/>
+        </p:nvSpPr>
+        <p:spPr>
+          <a:xfrm>
+            <a:off x="6096059" y="4500900"/>
+            <a:ext cx="5232059" cy="151200"/>
+          </a:xfrm>
+          <a:prstGeom prst="rect">
+            <a:avLst/>
+          </a:prstGeom>
+          <a:noFill/>
+        </p:spPr>
+        <p:txBody>
+          <a:bodyPr wrap="square" lIns="0" rIns="0" tIns="0" bIns="0" anchor="t">
+            <a:spAutoFit/>
+          </a:bodyPr>
+          <a:lstStyle/>
+          <a:p>
+            <a:pPr algn="l"/>
+            <a:r>
+              <a:rPr sz="1200" b="0" i="0">
+                <a:solidFill>
+                  <a:srgbClr val="555E5B"/>
+                </a:solidFill>
+                <a:latin typeface="Arial"/>
+              </a:rPr>
+              <a:t>M3 · USD 7.090.000</a:t>
+            </a:r>
+          </a:p>
+        </p:txBody>
+      </p:sp>
+      <p:sp>
+        <p:nvSpPr>
+          <p:cNvPr id="27" name="Rectangle 26"/>
+          <p:cNvSpPr/>
+          <p:nvPr/>
+        </p:nvSpPr>
+        <p:spPr>
+          <a:xfrm>
+            <a:off x="684000" y="4673700"/>
+            <a:ext cx="10824119" cy="9525"/>
+          </a:xfrm>
+          <a:prstGeom prst="rect">
+            <a:avLst/>
+          </a:prstGeom>
+          <a:solidFill>
+            <a:srgbClr val="C2C8C5"/>
+          </a:solidFill>
+          <a:ln>
+            <a:noFill/>
+          </a:ln>
+          <a:effectLst/>
+        </p:spPr>
+        <p:style>
+          <a:lnRef idx="1">
+            <a:schemeClr val="accent1"/>
+          </a:lnRef>
+          <a:fillRef idx="3">
+            <a:schemeClr val="accent1"/>
+          </a:fillRef>
+          <a:effectRef idx="2">
+            <a:schemeClr val="accent1"/>
+          </a:effectRef>
+          <a:fontRef idx="minor">
+            <a:schemeClr val="lt1"/>
+          </a:fontRef>
+        </p:style>
+        <p:txBody>
+          <a:bodyPr rtlCol="0" anchor="ctr"/>
+          <a:lstStyle/>
+          <a:p>
+            <a:pPr algn="ctr"/>
+          </a:p>
+        </p:txBody>
+      </p:sp>
+      <p:sp>
+        <p:nvSpPr>
+          <p:cNvPr id="28" name="TextBox 27"/>
+          <p:cNvSpPr txBox="1"/>
+          <p:nvPr/>
+        </p:nvSpPr>
+        <p:spPr>
+          <a:xfrm>
+            <a:off x="684000" y="4745700"/>
+            <a:ext cx="1551859" cy="432000"/>
+          </a:xfrm>
+          <a:prstGeom prst="rect">
+            <a:avLst/>
+          </a:prstGeom>
+          <a:noFill/>
+        </p:spPr>
+        <p:txBody>
+          <a:bodyPr wrap="square" lIns="0" rIns="0" tIns="0" bIns="0" anchor="t">
+            <a:spAutoFit/>
+          </a:bodyPr>
+          <a:lstStyle/>
+          <a:p>
+            <a:pPr algn="l">
+              <a:lnSpc>
+                <a:spcPct val="95000"/>
+              </a:lnSpc>
+            </a:pPr>
+            <a:r>
+              <a:rPr sz="2200" b="1" i="0">
+                <a:solidFill>
+                  <a:srgbClr val="7A4E00"/>
+                </a:solidFill>
+                <a:latin typeface="Georgia"/>
+              </a:rPr>
+              <a:t>57</a:t>
+            </a:r>
+          </a:p>
+        </p:txBody>
+      </p:sp>
+      <p:sp>
+        <p:nvSpPr>
+          <p:cNvPr id="29" name="TextBox 28"/>
+          <p:cNvSpPr txBox="1"/>
+          <p:nvPr/>
+        </p:nvSpPr>
+        <p:spPr>
+          <a:xfrm>
+            <a:off x="2415859" y="4745700"/>
+            <a:ext cx="3392200" cy="576000"/>
+          </a:xfrm>
+          <a:prstGeom prst="rect">
+            <a:avLst/>
+          </a:prstGeom>
+          <a:noFill/>
+        </p:spPr>
+        <p:txBody>
+          <a:bodyPr wrap="square" lIns="0" rIns="0" tIns="0" bIns="0" anchor="t">
+            <a:spAutoFit/>
+          </a:bodyPr>
+          <a:lstStyle/>
+          <a:p>
+            <a:pPr algn="l">
+              <a:lnSpc>
+                <a:spcPct val="120000"/>
+              </a:lnSpc>
+            </a:pPr>
+            <a:r>
+              <a:rPr sz="1500" b="0" i="0">
+                <a:solidFill>
+                  <a:srgbClr val="04110F"/>
+                </a:solidFill>
+                <a:latin typeface="Arial"/>
+              </a:rPr>
+              <a:t>La ventana sigue abierta, y se cierra sola</a:t>
+            </a:r>
+          </a:p>
+        </p:txBody>
+      </p:sp>
+      <p:sp>
+        <p:nvSpPr>
+          <p:cNvPr id="30" name="TextBox 29"/>
+          <p:cNvSpPr txBox="1"/>
+          <p:nvPr/>
+        </p:nvSpPr>
+        <p:spPr>
+          <a:xfrm>
+            <a:off x="6096059" y="4702500"/>
+            <a:ext cx="5232059" cy="474300"/>
+          </a:xfrm>
+          <a:prstGeom prst="rect">
+            <a:avLst/>
+          </a:prstGeom>
+          <a:noFill/>
+        </p:spPr>
+        <p:txBody>
+          <a:bodyPr wrap="square" lIns="0" rIns="0" tIns="0" bIns="0" anchor="t">
+            <a:spAutoFit/>
+          </a:bodyPr>
+          <a:lstStyle/>
+          <a:p>
+            <a:pPr algn="l">
+              <a:lnSpc>
+                <a:spcPct val="115000"/>
+              </a:lnSpc>
+            </a:pPr>
+            <a:r>
+              <a:rPr sz="1600" b="1" i="0">
+                <a:solidFill>
+                  <a:srgbClr val="004C45"/>
+                </a:solidFill>
+                <a:latin typeface="Arial"/>
+              </a:rPr>
+              <a:t>Banco genético propio: llegar primero</a:t>
+            </a:r>
+          </a:p>
+        </p:txBody>
+      </p:sp>
+      <p:sp>
+        <p:nvSpPr>
+          <p:cNvPr id="31" name="TextBox 30"/>
+          <p:cNvSpPr txBox="1"/>
+          <p:nvPr/>
+        </p:nvSpPr>
+        <p:spPr>
+          <a:xfrm>
+            <a:off x="6096059" y="5198400"/>
+            <a:ext cx="5232059" cy="151200"/>
+          </a:xfrm>
+          <a:prstGeom prst="rect">
+            <a:avLst/>
+          </a:prstGeom>
+          <a:noFill/>
+        </p:spPr>
+        <p:txBody>
+          <a:bodyPr wrap="square" lIns="0" rIns="0" tIns="0" bIns="0" anchor="t">
+            <a:spAutoFit/>
+          </a:bodyPr>
+          <a:lstStyle/>
+          <a:p>
+            <a:pPr algn="l"/>
+            <a:r>
+              <a:rPr sz="1200" b="0" i="0">
+                <a:solidFill>
+                  <a:srgbClr val="555E5B"/>
+                </a:solidFill>
+                <a:latin typeface="Arial"/>
+              </a:rPr>
+              <a:t>M4 · USD 1.268.000</a:t>
+            </a:r>
+          </a:p>
+        </p:txBody>
+      </p:sp>
+      <p:sp>
+        <p:nvSpPr>
+          <p:cNvPr id="32" name="Rectangle 31"/>
+          <p:cNvSpPr/>
+          <p:nvPr/>
+        </p:nvSpPr>
+        <p:spPr>
+          <a:xfrm>
+            <a:off x="684000" y="5490000"/>
+            <a:ext cx="10824119" cy="15875"/>
+          </a:xfrm>
+          <a:prstGeom prst="rect">
+            <a:avLst/>
+          </a:prstGeom>
+          <a:solidFill>
+            <a:srgbClr val="004C45"/>
+          </a:solidFill>
+          <a:ln>
+            <a:noFill/>
+          </a:ln>
+          <a:effectLst/>
+        </p:spPr>
+        <p:style>
+          <a:lnRef idx="1">
+            <a:schemeClr val="accent1"/>
+          </a:lnRef>
+          <a:fillRef idx="3">
+            <a:schemeClr val="accent1"/>
+          </a:fillRef>
+          <a:effectRef idx="2">
+            <a:schemeClr val="accent1"/>
+          </a:effectRef>
+          <a:fontRef idx="minor">
+            <a:schemeClr val="lt1"/>
+          </a:fontRef>
+        </p:style>
+        <p:txBody>
+          <a:bodyPr rtlCol="0" anchor="ctr"/>
+          <a:lstStyle/>
+          <a:p>
+            <a:pPr algn="ctr"/>
+          </a:p>
+        </p:txBody>
+      </p:sp>
+      <p:sp>
+        <p:nvSpPr>
+          <p:cNvPr id="33" name="TextBox 32"/>
+          <p:cNvSpPr txBox="1"/>
+          <p:nvPr/>
+        </p:nvSpPr>
+        <p:spPr>
+          <a:xfrm>
+            <a:off x="684000" y="5562000"/>
+            <a:ext cx="10824119" cy="720000"/>
+          </a:xfrm>
+          <a:prstGeom prst="rect">
+            <a:avLst/>
+          </a:prstGeom>
+          <a:noFill/>
+        </p:spPr>
+        <p:txBody>
+          <a:bodyPr wrap="square" lIns="0" rIns="0" tIns="0" bIns="0" anchor="t">
+            <a:spAutoFit/>
+          </a:bodyPr>
+          <a:lstStyle/>
+          <a:p>
+            <a:pPr algn="l">
+              <a:lnSpc>
+                <a:spcPct val="130000"/>
+              </a:lnSpc>
+            </a:pPr>
+            <a:r>
+              <a:rPr sz="1300" b="0" i="0">
+                <a:solidFill>
+                  <a:srgbClr val="04110F"/>
+                </a:solidFill>
+                <a:latin typeface="Arial"/>
+              </a:rPr>
+              <a:t>Y el monitoreo no es un principio: es la prueba. Las patentes de la cúrcuma, del neem y del frijol se tumbaron por anterioridad documentada, no por falta de divulgación de origen. Un pueblo que registra sistemáticamente está fabricando el único argumento que ha ganado.</a:t>
+            </a:r>
+          </a:p>
+        </p:txBody>
+      </p:sp>
+      <p:sp>
+        <p:nvSpPr>
+          <p:cNvPr id="34" name="TextBox 33"/>
+          <p:cNvSpPr txBox="1"/>
+          <p:nvPr/>
+        </p:nvSpPr>
+        <p:spPr>
+          <a:xfrm>
+            <a:off x="684000" y="6372000"/>
+            <a:ext cx="10824119" cy="288000"/>
+          </a:xfrm>
+          <a:prstGeom prst="rect">
+            <a:avLst/>
+          </a:prstGeom>
+          <a:noFill/>
+        </p:spPr>
+        <p:txBody>
+          <a:bodyPr wrap="square" lIns="0" rIns="0" tIns="0" bIns="0" anchor="t">
+            <a:spAutoFit/>
+          </a:bodyPr>
+          <a:lstStyle/>
+          <a:p>
+            <a:pPr algn="l"/>
+            <a:r>
+              <a:rPr sz="1200" b="0" i="0">
+                <a:solidFill>
+                  <a:srgbClr val="555E5B"/>
+                </a:solidFill>
+                <a:latin typeface="Arial"/>
+              </a:rPr>
+              <a:t>Fuente: ONIC, 2026.</a:t>
+            </a:r>
+          </a:p>
+        </p:txBody>
+      </p:sp>
+    </p:spTree>
+  </p:cSld>
+  <p:clrMapOvr>
+    <a:masterClrMapping/>
+  </p:clrMapOvr>
+</p:sld>
+</file>
+
+<file path=ppt/slides/slide17.xml><?xml version="1.0" encoding="utf-8"?>
+<p:sld xmlns:a="http://schemas.openxmlformats.org/drawingml/2006/main" xmlns:p="http://schemas.openxmlformats.org/presentationml/2006/main" xmlns:r="http://schemas.openxmlformats.org/officeDocument/2006/relationships">
+  <p:cSld>
+    <p:spTree>
+      <p:nvGrpSpPr>
+        <p:cNvPr id="1" name=""/>
+        <p:cNvGrpSpPr/>
+        <p:nvPr/>
+      </p:nvGrpSpPr>
+      <p:grpSpPr/>
+      <p:sp>
+        <p:nvSpPr>
+          <p:cNvPr id="2" name="Rectangle 1"/>
+          <p:cNvSpPr/>
+          <p:nvPr/>
+        </p:nvSpPr>
+        <p:spPr>
+          <a:xfrm>
+            <a:off x="0" y="0"/>
+            <a:ext cx="12192119" cy="6858000"/>
+          </a:xfrm>
+          <a:prstGeom prst="rect">
+            <a:avLst/>
+          </a:prstGeom>
+          <a:solidFill>
+            <a:srgbClr val="F2EFE6"/>
+          </a:solidFill>
+          <a:ln>
+            <a:noFill/>
+          </a:ln>
+          <a:effectLst/>
+        </p:spPr>
+        <p:style>
+          <a:lnRef idx="1">
+            <a:schemeClr val="accent1"/>
+          </a:lnRef>
+          <a:fillRef idx="3">
+            <a:schemeClr val="accent1"/>
+          </a:fillRef>
+          <a:effectRef idx="2">
+            <a:schemeClr val="accent1"/>
+          </a:effectRef>
+          <a:fontRef idx="minor">
+            <a:schemeClr val="lt1"/>
+          </a:fontRef>
+        </p:style>
+        <p:txBody>
+          <a:bodyPr rtlCol="0" anchor="ctr"/>
+          <a:lstStyle/>
+          <a:p>
+            <a:pPr algn="ctr"/>
+          </a:p>
+        </p:txBody>
+      </p:sp>
+      <p:sp>
+        <p:nvSpPr>
+          <p:cNvPr id="3" name="TextBox 2"/>
+          <p:cNvSpPr txBox="1"/>
+          <p:nvPr/>
+        </p:nvSpPr>
+        <p:spPr>
+          <a:xfrm>
+            <a:off x="684000" y="413999"/>
+            <a:ext cx="6494471" cy="288000"/>
+          </a:xfrm>
+          <a:prstGeom prst="rect">
+            <a:avLst/>
+          </a:prstGeom>
+          <a:noFill/>
+        </p:spPr>
+        <p:txBody>
+          <a:bodyPr wrap="square" lIns="0" rIns="0" tIns="0" bIns="0" anchor="t">
+            <a:spAutoFit/>
+          </a:bodyPr>
+          <a:lstStyle/>
+          <a:p>
+            <a:pPr algn="l"/>
+            <a:r>
+              <a:rPr sz="1300" b="1" i="0">
+                <a:solidFill>
+                  <a:srgbClr val="004C45"/>
+                </a:solidFill>
+                <a:latin typeface="Arial"/>
+              </a:rPr>
+              <a:t>13 · LO QUE DEJAMOS AQUÍ</a:t>
             </a:r>
           </a:p>
         </p:txBody>

</xml_diff>